<commit_message>
Slides: live Zetaris + Nemotron run on slide 5, test count
Co-Authored-By: Claude Opus 5.5 <noreply@anthropic.com>
</commit_message>
<xml_diff>
--- a/submission/GapWise.pptx
+++ b/submission/GapWise.pptx
@@ -4220,11 +4220,11 @@
             </a:avLst>
           </a:prstGeom>
           <a:solidFill>
-            <a:srgbClr val="FDECEC"/>
+            <a:srgbClr val="E8F6EE"/>
           </a:solidFill>
           <a:ln w="12700">
             <a:solidFill>
-              <a:srgbClr val="FDECEC"/>
+              <a:srgbClr val="E8F6EE"/>
             </a:solidFill>
             <a:prstDash val="solid"/>
           </a:ln>
@@ -4257,10 +4257,10 @@
             <a:r>
               <a:rPr lang="en-US" sz="1300" b="1" dirty="0">
                 <a:solidFill>
-                  <a:srgbClr val="B42318"/>
-                </a:solidFill>
-              </a:rPr>
-              <a:t>Live run, 27 Oct 2026</a:t>
+                  <a:srgbClr val="1E7A4C"/>
+                </a:solidFill>
+              </a:rPr>
+              <a:t>Live run, 27 Oct 2026, 15:09 UTC</a:t>
             </a:r>
             <a:endParaRPr lang="en-US" sz="1300" dirty="0"/>
           </a:p>
@@ -4299,7 +4299,7 @@
                   <a:srgbClr val="111827"/>
                 </a:solidFill>
               </a:rPr>
-              <a:t>nvidia/nemotron-3.5-bolt-e4b claimed the gap was "fully explained".</a:t>
+              <a:t>Nemotron (via Nightshift) wrote 3 SQL queries; Zetaris ran them. One used a column that does not exist: the error went back to the model.</a:t>
             </a:r>
             <a:endParaRPr lang="en-US" sz="1300" dirty="0"/>
           </a:p>
@@ -4316,7 +4316,7 @@
                   <a:srgbClr val="111827"/>
                 </a:solidFill>
               </a:rPr>
-              <a:t>ValidatorAgent rejected it and asked for a revision. The revision made the same claim and was rejected again, so GapWise kept the computed numbers.</a:t>
+              <a:t>Its answer, "the gap is not fully explained… iUSD at a placeholder price", cited only known evidence, so ValidatorAgent accepted it.</a:t>
             </a:r>
             <a:endParaRPr lang="en-US" sz="1300" dirty="0"/>
           </a:p>
@@ -5585,7 +5585,7 @@
                   <a:srgbClr val="111827"/>
                 </a:solidFill>
               </a:rPr>
-              <a:t>25 new tests (137 total passing)</a:t>
+              <a:t>26 new tests (138 total passing)</a:t>
             </a:r>
             <a:endParaRPr lang="en-US" sz="1300" dirty="0"/>
           </a:p>

</xml_diff>

<commit_message>
Presentation: GapWise name only in README, docs, slides and site; pre-existing parts stated once, neutrally; GAPWISE_NETWORK / GAPWISE_URL aliases
Co-Authored-By: Claude Opus 5.5 <noreply@anthropic.com>
</commit_message>
<xml_diff>
--- a/submission/GapWise.pptx
+++ b/submission/GapWise.pptx
@@ -5298,7 +5298,7 @@
                   <a:srgbClr val="475569"/>
                 </a:solidFill>
               </a:rPr>
-              <a:t>Existed before 22 Oct (declared)</a:t>
+              <a:t>Foundation, built before 22 Oct (declared)</a:t>
             </a:r>
             <a:endParaRPr lang="en-US" sz="1500" dirty="0"/>
           </a:p>
@@ -5338,7 +5338,7 @@
                   <a:srgbClr val="111827"/>
                 </a:solidFill>
               </a:rPr>
-              <a:t>ZeroGap monitor: collectors for 3 ledgers + platform API</a:t>
+              <a:t>Data collectors for 3 ledgers + platform API</a:t>
             </a:r>
             <a:endParaRPr lang="en-US" sz="1300" dirty="0"/>
           </a:p>

</xml_diff>